<commit_message>
Congresdeck op het protocolmanuscript gebaseerd
Het manuscript volledig nagelezen en het congresdeck erop gezet: de these
vooraan, de drie strategieen die elk apart faalden, waarom de studie nu pas
kan, en een eigen blok voor eindpunten en analyse.

De steekproefberekening staat nu op de cijfers van het manuscript (41 events,
108 naar 127 naar 130; 50 per groep naar 118) in plaats van de oudere
protocolcijfers, met een aparte dia voor de gezamenlijke power van 74 tot 84%.
Het analyseplan volgt Cox met Fine-Gray en beta-regressie in plaats van
chi-kwadraat en een t-toets.

Het primaire analysepunt voor therapietrouw staat volgens het manuscript op
12 maanden, recidief op 18. PARADISE_BRONNEN.md legt dat vast en somt de
plaatsen op waar het protocol nog moet volgen.

Co-Authored-By: Claude Opus 5 <noreply@anthropic.com>
</commit_message>
<xml_diff>
--- a/PARADISE_presentatie/PARADISE_board.pptx
+++ b/PARADISE_presentatie/PARADISE_board.pptx
@@ -56533,7 +56533,7 @@
                 </a:solidFill>
                 <a:latin typeface="Segoe UI"/>
               </a:rPr>
-              <a:t>Recidief én draagtijd, beide op 18 maanden</a:t>
+              <a:t>Recidief op 18 maanden, draagtijd op 12</a:t>
             </a:r>
           </a:p>
         </p:txBody>
@@ -63609,7 +63609,7 @@
         <p:spPr>
           <a:xfrm>
             <a:off x="952476" y="5549761"/>
-            <a:ext cx="10286742" cy="444488"/>
+            <a:ext cx="10286742" cy="380990"/>
           </a:xfrm>
           <a:prstGeom prst="rect">
             <a:avLst/>
@@ -64514,8 +64514,8 @@
         </p:nvSpPr>
         <p:spPr>
           <a:xfrm>
-            <a:off x="634984" y="5371965"/>
-            <a:ext cx="10921726" cy="736581"/>
+            <a:off x="634984" y="4992194"/>
+            <a:ext cx="10921726" cy="1116352"/>
           </a:xfrm>
           <a:prstGeom prst="roundRect">
             <a:avLst>
@@ -64562,8 +64562,8 @@
         </p:nvSpPr>
         <p:spPr>
           <a:xfrm>
-            <a:off x="952476" y="5549761"/>
-            <a:ext cx="10286742" cy="444488"/>
+            <a:off x="952476" y="5169989"/>
+            <a:ext cx="10286742" cy="760761"/>
           </a:xfrm>
           <a:prstGeom prst="rect">
             <a:avLst/>

</xml_diff>